<commit_message>
Handle cross-run Chinese-English spacing
</commit_message>
<xml_diff>
--- a/examples/after/sample.pptx
+++ b/examples/after/sample.pptx
@@ -15,6 +15,40 @@
               <a:t>河蚬As暴露</a:t>
             </a:r>
           </a:p>
+          <a:p>
+            <a:r>
+              <a:rPr>
+                <a:latin typeface="Times New Roman"/>
+                <a:ea typeface="宋体"/>
+                <a:cs typeface="Times New Roman"/>
+              </a:rPr>
+              <a:t>贝类</a:t>
+            </a:r>
+            <a:r>
+              <a:rPr>
+                <a:latin typeface="Times New Roman"/>
+                <a:ea typeface="宋体"/>
+                <a:cs typeface="Times New Roman"/>
+              </a:rPr>
+              <a:t/>
+            </a:r>
+            <a:r>
+              <a:rPr>
+                <a:latin typeface="Times New Roman"/>
+                <a:ea typeface="宋体"/>
+                <a:cs typeface="Times New Roman"/>
+              </a:rPr>
+              <a:t>As</a:t>
+            </a:r>
+            <a:r>
+              <a:rPr>
+                <a:latin typeface="Times New Roman"/>
+                <a:ea typeface="宋体"/>
+                <a:cs typeface="Times New Roman"/>
+              </a:rPr>
+              <a:t>暴露</a:t>
+            </a:r>
+          </a:p>
         </ns0:txBody>
       </ns0:sp>
     </ns0:spTree>

</xml_diff>